<commit_message>
TL10 v1.0 Feinschliff: Modul + Downloads aktualisiert (3 Niedrig-Befunde)
Co-Authored-By: Claude Opus 4.8 <noreply@anthropic.com>
</commit_message>
<xml_diff>
--- a/protected-downloads/praesentation/TL10.pptx
+++ b/protected-downloads/praesentation/TL10.pptx
@@ -11122,7 +11122,7 @@
                 </a:solidFill>
                 <a:latin typeface="Consolas"/>
               </a:rPr>
-              <a:t>12:35       </a:t>
+              <a:t>12:40       </a:t>
             </a:r>
             <a:r>
               <a:rPr sz="1200" b="1">
@@ -11150,7 +11150,7 @@
                 </a:solidFill>
                 <a:latin typeface="Consolas"/>
               </a:rPr>
-              <a:t>12:40       </a:t>
+              <a:t>12:45       </a:t>
             </a:r>
             <a:r>
               <a:rPr sz="1200" b="1">

</xml_diff>